<commit_message>
seminar 10장: 3x3 을 히트맵 대신 덱 표로 + Origin CSV 두 개
1저자 판단: 숫자 아홉 개짜리를 파이썬 히트맵으로 그리면 '파이썬 그림 티' 가 난다.
add_table 로 덱 표 양식에 넣어 나머지 장과 통일한다.
  - build_seminar_slide 에 table= 지원 추가 (그림 옆에 세로 중앙 정렬)
  - fig_site_grid 함수는 남겨 둔다 (수치 검산·다른 용도)

Origin 재작도용 CSV (열 이름 명시적):
  seminar_table_anion_site.csv - 왼쪽 막대 3행 (wyckoff / label / n_candidates)
  seminar_table_site_grid.csv  - 오른쪽 3x3 + 행·열 합계, 'counts are STRUCTURES,
                                 not compounds' 경고 포함

Co-Authored-By: Claude Opus 5 <noreply@anthropic.com>
Claude-Session: https://claude.ai/code/session_01L44TWYrHkcm4PH5ihWSSCw
</commit_message>
<xml_diff>
--- a/docs/Slide10_structure_generation.pptx
+++ b/docs/Slide10_structure_generation.pptx
@@ -1298,7 +1298,7 @@
                 <a:ea typeface="Arial"/>
                 <a:cs typeface="Arial"/>
               </a:rPr>
-              <a:t>Configuration: one specific arrangement of atoms in the cell  ·  24g / 48h / 4b / 4a / 16e / 4d: Wyckoff labels for the sublattice positions</a:t>
+              <a:t>Configuration: one specific arrangement of atoms in the cell  ·  24g / 48h / 4b: Wyckoff labels for the sublattice positions</a:t>
             </a:r>
           </a:p>
         </p:txBody>
@@ -1901,38 +1901,418 @@
         </p:blipFill>
         <p:spPr>
           <a:xfrm>
-            <a:off x="502920" y="2889503"/>
-            <a:ext cx="3968496" cy="1700784"/>
+            <a:off x="502920" y="2820924"/>
+            <a:ext cx="4160520" cy="1783080"/>
           </a:xfrm>
           <a:prstGeom prst="rect">
             <a:avLst/>
           </a:prstGeom>
         </p:spPr>
       </p:pic>
-      <p:pic xmlns:a="http://schemas.openxmlformats.org/drawingml/2006/main" xmlns:r="http://schemas.openxmlformats.org/officeDocument/2006/relationships">
-        <p:nvPicPr>
-          <p:cNvPr id="32" name="Picture 31" descr="step2_site_grid.png"/>
-          <p:cNvPicPr>
-            <a:picLocks noChangeAspect="1"/>
-          </p:cNvPicPr>
+      <p:graphicFrame xmlns:a="http://schemas.openxmlformats.org/drawingml/2006/main">
+        <p:nvGraphicFramePr>
+          <p:cNvPr id="32" name="Table 31"/>
+          <p:cNvGraphicFramePr>
+            <a:graphicFrameLocks noGrp="1"/>
+          </p:cNvGraphicFramePr>
           <p:nvPr/>
-        </p:nvPicPr>
-        <p:blipFill>
-          <a:blip r:embed="rId5"/>
-          <a:stretch>
-            <a:fillRect/>
-          </a:stretch>
-        </p:blipFill>
-        <p:spPr>
-          <a:xfrm>
-            <a:off x="4672583" y="2869860"/>
-            <a:ext cx="3968496" cy="1740071"/>
-          </a:xfrm>
-          <a:prstGeom prst="rect">
-            <a:avLst/>
-          </a:prstGeom>
-        </p:spPr>
-      </p:pic>
+        </p:nvGraphicFramePr>
+        <p:xfrm>
+          <a:off x="4864608" y="3172968"/>
+          <a:ext cx="3776469" cy="1031440"/>
+        </p:xfrm>
+        <a:graphic>
+          <a:graphicData uri="http://schemas.openxmlformats.org/drawingml/2006/table">
+            <a:tbl>
+              <a:tblPr firstRow="1">
+                <a:tableStyleId>{5C22544A-7EE6-4342-B048-85BDC9FD1C3A}</a:tableStyleId>
+              </a:tblPr>
+              <a:tblGrid>
+                <a:gridCol w="1325880"/>
+                <a:gridCol w="816863"/>
+                <a:gridCol w="816863"/>
+                <a:gridCol w="816863"/>
+              </a:tblGrid>
+              <a:tr h="257860">
+                <a:tc>
+                  <a:txBody>
+                    <a:bodyPr/>
+                    <a:lstStyle/>
+                    <a:p>
+                      <a:pPr algn="l"/>
+                      <a:r>
+                        <a:rPr sz="1200" b="1">
+                          <a:solidFill>
+                            <a:srgbClr val="1F2937"/>
+                          </a:solidFill>
+                          <a:latin typeface="Arial"/>
+                        </a:rPr>
+                        <a:t/>
+                      </a:r>
+                    </a:p>
+                  </a:txBody>
+                  <a:tcPr marL="64008" marR="64008" marT="18288" marB="18288">
+                    <a:solidFill>
+                      <a:srgbClr val="EEF2F7"/>
+                    </a:solidFill>
+                  </a:tcPr>
+                </a:tc>
+                <a:tc>
+                  <a:txBody>
+                    <a:bodyPr/>
+                    <a:lstStyle/>
+                    <a:p>
+                      <a:pPr algn="ctr"/>
+                      <a:r>
+                        <a:rPr sz="1200" b="1">
+                          <a:solidFill>
+                            <a:srgbClr val="1F2937"/>
+                          </a:solidFill>
+                          <a:latin typeface="Arial"/>
+                        </a:rPr>
+                        <a:t>free S</a:t>
+                      </a:r>
+                    </a:p>
+                  </a:txBody>
+                  <a:tcPr marL="64008" marR="64008" marT="18288" marB="18288">
+                    <a:solidFill>
+                      <a:srgbClr val="EEF2F7"/>
+                    </a:solidFill>
+                  </a:tcPr>
+                </a:tc>
+                <a:tc>
+                  <a:txBody>
+                    <a:bodyPr/>
+                    <a:lstStyle/>
+                    <a:p>
+                      <a:pPr algn="ctr"/>
+                      <a:r>
+                        <a:rPr sz="1200" b="1">
+                          <a:solidFill>
+                            <a:srgbClr val="1F2937"/>
+                          </a:solidFill>
+                          <a:latin typeface="Arial"/>
+                        </a:rPr>
+                        <a:t>PS₄ corner</a:t>
+                      </a:r>
+                    </a:p>
+                  </a:txBody>
+                  <a:tcPr marL="64008" marR="64008" marT="18288" marB="18288">
+                    <a:solidFill>
+                      <a:srgbClr val="EEF2F7"/>
+                    </a:solidFill>
+                  </a:tcPr>
+                </a:tc>
+                <a:tc>
+                  <a:txBody>
+                    <a:bodyPr/>
+                    <a:lstStyle/>
+                    <a:p>
+                      <a:pPr algn="ctr"/>
+                      <a:r>
+                        <a:rPr sz="1200" b="1">
+                          <a:solidFill>
+                            <a:srgbClr val="1F2937"/>
+                          </a:solidFill>
+                          <a:latin typeface="Arial"/>
+                        </a:rPr>
+                        <a:t>halide</a:t>
+                      </a:r>
+                    </a:p>
+                  </a:txBody>
+                  <a:tcPr marL="64008" marR="64008" marT="18288" marB="18288">
+                    <a:solidFill>
+                      <a:srgbClr val="EEF2F7"/>
+                    </a:solidFill>
+                  </a:tcPr>
+                </a:tc>
+              </a:tr>
+              <a:tr h="257860">
+                <a:tc>
+                  <a:txBody>
+                    <a:bodyPr/>
+                    <a:lstStyle/>
+                    <a:p>
+                      <a:pPr algn="l"/>
+                      <a:r>
+                        <a:rPr sz="1200" b="0">
+                          <a:solidFill>
+                            <a:srgbClr val="374151"/>
+                          </a:solidFill>
+                          <a:latin typeface="Arial"/>
+                        </a:rPr>
+                        <a:t>Li 24g</a:t>
+                      </a:r>
+                    </a:p>
+                  </a:txBody>
+                  <a:tcPr marL="64008" marR="64008" marT="18288" marB="18288">
+                    <a:solidFill>
+                      <a:srgbClr val="FFFFFF"/>
+                    </a:solidFill>
+                  </a:tcPr>
+                </a:tc>
+                <a:tc>
+                  <a:txBody>
+                    <a:bodyPr/>
+                    <a:lstStyle/>
+                    <a:p>
+                      <a:pPr algn="ctr"/>
+                      <a:r>
+                        <a:rPr sz="1200" b="1">
+                          <a:solidFill>
+                            <a:srgbClr val="2563EB"/>
+                          </a:solidFill>
+                          <a:latin typeface="Arial"/>
+                        </a:rPr>
+                        <a:t>1050</a:t>
+                      </a:r>
+                    </a:p>
+                  </a:txBody>
+                  <a:tcPr marL="64008" marR="64008" marT="18288" marB="18288">
+                    <a:solidFill>
+                      <a:srgbClr val="FFFFFF"/>
+                    </a:solidFill>
+                  </a:tcPr>
+                </a:tc>
+                <a:tc>
+                  <a:txBody>
+                    <a:bodyPr/>
+                    <a:lstStyle/>
+                    <a:p>
+                      <a:pPr algn="ctr"/>
+                      <a:r>
+                        <a:rPr sz="1200" b="0">
+                          <a:solidFill>
+                            <a:srgbClr val="374151"/>
+                          </a:solidFill>
+                          <a:latin typeface="Arial"/>
+                        </a:rPr>
+                        <a:t>810</a:t>
+                      </a:r>
+                    </a:p>
+                  </a:txBody>
+                  <a:tcPr marL="64008" marR="64008" marT="18288" marB="18288">
+                    <a:solidFill>
+                      <a:srgbClr val="FFFFFF"/>
+                    </a:solidFill>
+                  </a:tcPr>
+                </a:tc>
+                <a:tc>
+                  <a:txBody>
+                    <a:bodyPr/>
+                    <a:lstStyle/>
+                    <a:p>
+                      <a:pPr algn="ctr"/>
+                      <a:r>
+                        <a:rPr sz="1200" b="0">
+                          <a:solidFill>
+                            <a:srgbClr val="374151"/>
+                          </a:solidFill>
+                          <a:latin typeface="Arial"/>
+                        </a:rPr>
+                        <a:t>600</a:t>
+                      </a:r>
+                    </a:p>
+                  </a:txBody>
+                  <a:tcPr marL="64008" marR="64008" marT="18288" marB="18288">
+                    <a:solidFill>
+                      <a:srgbClr val="FFFFFF"/>
+                    </a:solidFill>
+                  </a:tcPr>
+                </a:tc>
+              </a:tr>
+              <a:tr h="257860">
+                <a:tc>
+                  <a:txBody>
+                    <a:bodyPr/>
+                    <a:lstStyle/>
+                    <a:p>
+                      <a:pPr algn="l"/>
+                      <a:r>
+                        <a:rPr sz="1200" b="0">
+                          <a:solidFill>
+                            <a:srgbClr val="374151"/>
+                          </a:solidFill>
+                          <a:latin typeface="Arial"/>
+                        </a:rPr>
+                        <a:t>P 4b</a:t>
+                      </a:r>
+                    </a:p>
+                  </a:txBody>
+                  <a:tcPr marL="64008" marR="64008" marT="18288" marB="18288">
+                    <a:solidFill>
+                      <a:srgbClr val="FFFFFF"/>
+                    </a:solidFill>
+                  </a:tcPr>
+                </a:tc>
+                <a:tc>
+                  <a:txBody>
+                    <a:bodyPr/>
+                    <a:lstStyle/>
+                    <a:p>
+                      <a:pPr algn="ctr"/>
+                      <a:r>
+                        <a:rPr sz="1200" b="0">
+                          <a:solidFill>
+                            <a:srgbClr val="374151"/>
+                          </a:solidFill>
+                          <a:latin typeface="Arial"/>
+                        </a:rPr>
+                        <a:t>375</a:t>
+                      </a:r>
+                    </a:p>
+                  </a:txBody>
+                  <a:tcPr marL="64008" marR="64008" marT="18288" marB="18288">
+                    <a:solidFill>
+                      <a:srgbClr val="FFFFFF"/>
+                    </a:solidFill>
+                  </a:tcPr>
+                </a:tc>
+                <a:tc>
+                  <a:txBody>
+                    <a:bodyPr/>
+                    <a:lstStyle/>
+                    <a:p>
+                      <a:pPr algn="ctr"/>
+                      <a:r>
+                        <a:rPr sz="1200" b="0">
+                          <a:solidFill>
+                            <a:srgbClr val="374151"/>
+                          </a:solidFill>
+                          <a:latin typeface="Arial"/>
+                        </a:rPr>
+                        <a:t>270</a:t>
+                      </a:r>
+                    </a:p>
+                  </a:txBody>
+                  <a:tcPr marL="64008" marR="64008" marT="18288" marB="18288">
+                    <a:solidFill>
+                      <a:srgbClr val="FFFFFF"/>
+                    </a:solidFill>
+                  </a:tcPr>
+                </a:tc>
+                <a:tc>
+                  <a:txBody>
+                    <a:bodyPr/>
+                    <a:lstStyle/>
+                    <a:p>
+                      <a:pPr algn="ctr"/>
+                      <a:r>
+                        <a:rPr sz="1200" b="0">
+                          <a:solidFill>
+                            <a:srgbClr val="374151"/>
+                          </a:solidFill>
+                          <a:latin typeface="Arial"/>
+                        </a:rPr>
+                        <a:t>180</a:t>
+                      </a:r>
+                    </a:p>
+                  </a:txBody>
+                  <a:tcPr marL="64008" marR="64008" marT="18288" marB="18288">
+                    <a:solidFill>
+                      <a:srgbClr val="FFFFFF"/>
+                    </a:solidFill>
+                  </a:tcPr>
+                </a:tc>
+              </a:tr>
+              <a:tr h="257860">
+                <a:tc>
+                  <a:txBody>
+                    <a:bodyPr/>
+                    <a:lstStyle/>
+                    <a:p>
+                      <a:pPr algn="l"/>
+                      <a:r>
+                        <a:rPr sz="1200" b="0">
+                          <a:solidFill>
+                            <a:srgbClr val="374151"/>
+                          </a:solidFill>
+                          <a:latin typeface="Arial"/>
+                        </a:rPr>
+                        <a:t>Li 48h</a:t>
+                      </a:r>
+                    </a:p>
+                  </a:txBody>
+                  <a:tcPr marL="64008" marR="64008" marT="18288" marB="18288">
+                    <a:solidFill>
+                      <a:srgbClr val="FFFFFF"/>
+                    </a:solidFill>
+                  </a:tcPr>
+                </a:tc>
+                <a:tc>
+                  <a:txBody>
+                    <a:bodyPr/>
+                    <a:lstStyle/>
+                    <a:p>
+                      <a:pPr algn="ctr"/>
+                      <a:r>
+                        <a:rPr sz="1200" b="0">
+                          <a:solidFill>
+                            <a:srgbClr val="374151"/>
+                          </a:solidFill>
+                          <a:latin typeface="Arial"/>
+                        </a:rPr>
+                        <a:t>120</a:t>
+                      </a:r>
+                    </a:p>
+                  </a:txBody>
+                  <a:tcPr marL="64008" marR="64008" marT="18288" marB="18288">
+                    <a:solidFill>
+                      <a:srgbClr val="FFFFFF"/>
+                    </a:solidFill>
+                  </a:tcPr>
+                </a:tc>
+                <a:tc>
+                  <a:txBody>
+                    <a:bodyPr/>
+                    <a:lstStyle/>
+                    <a:p>
+                      <a:pPr algn="ctr"/>
+                      <a:r>
+                        <a:rPr sz="1200" b="0">
+                          <a:solidFill>
+                            <a:srgbClr val="374151"/>
+                          </a:solidFill>
+                          <a:latin typeface="Arial"/>
+                        </a:rPr>
+                        <a:t>105</a:t>
+                      </a:r>
+                    </a:p>
+                  </a:txBody>
+                  <a:tcPr marL="64008" marR="64008" marT="18288" marB="18288">
+                    <a:solidFill>
+                      <a:srgbClr val="FFFFFF"/>
+                    </a:solidFill>
+                  </a:tcPr>
+                </a:tc>
+                <a:tc>
+                  <a:txBody>
+                    <a:bodyPr/>
+                    <a:lstStyle/>
+                    <a:p>
+                      <a:pPr algn="ctr"/>
+                      <a:r>
+                        <a:rPr sz="1200" b="0">
+                          <a:solidFill>
+                            <a:srgbClr val="374151"/>
+                          </a:solidFill>
+                          <a:latin typeface="Arial"/>
+                        </a:rPr>
+                        <a:t>105</a:t>
+                      </a:r>
+                    </a:p>
+                  </a:txBody>
+                  <a:tcPr marL="64008" marR="64008" marT="18288" marB="18288">
+                    <a:solidFill>
+                      <a:srgbClr val="FFFFFF"/>
+                    </a:solidFill>
+                  </a:tcPr>
+                </a:tc>
+              </a:tr>
+            </a:tbl>
+          </a:graphicData>
+        </a:graphic>
+      </p:graphicFrame>
       <p:sp xmlns:a="http://schemas.openxmlformats.org/drawingml/2006/main">
         <p:nvSpPr>
           <p:cNvPr id="33" name="TextBox 32"/>
@@ -1963,7 +2343,7 @@
                 </a:solidFill>
                 <a:latin typeface="Arial"/>
               </a:rPr>
-              <a:t>&lt; where the anion landed  ·  structures per site pair &gt;</a:t>
+              <a:t>&lt; where the anion landed  ·  structures per site pair (cation ↓ / anion →) &gt;</a:t>
             </a:r>
           </a:p>
         </p:txBody>

</xml_diff>

<commit_message>
seminar 10장: 3x3 을 confusion-matrix 양식 그림으로 (1저자 지정)
앞 판을 덱 표로 바꿨다가 되돌린다. 1저자가 보여준 참조 양식은 표가 아니라
confusion matrix 꼴 히트맵이었다:
  - 칸 안에 **수 + 비율** 두 줄
  - 컬러바(structures generated) + 축 제목(Cation site / Anion site)
  - 흰->네이비 순차 컬러맵, 글자색은 on_fill 로 자동
표보다 '어느 조합이 두꺼운가' 가 즉시 보인다.

Origin CSV 두 개는 그대로 유지 (재작도용).

Co-Authored-By: Claude Opus 5 <noreply@anthropic.com>
Claude-Session: https://claude.ai/code/session_01L44TWYrHkcm4PH5ihWSSCw
</commit_message>
<xml_diff>
--- a/docs/Slide10_structure_generation.pptx
+++ b/docs/Slide10_structure_generation.pptx
@@ -1901,418 +1901,38 @@
         </p:blipFill>
         <p:spPr>
           <a:xfrm>
-            <a:off x="502920" y="2820924"/>
-            <a:ext cx="4160520" cy="1783080"/>
+            <a:off x="502920" y="2880360"/>
+            <a:ext cx="3968496" cy="1700784"/>
           </a:xfrm>
           <a:prstGeom prst="rect">
             <a:avLst/>
           </a:prstGeom>
         </p:spPr>
       </p:pic>
-      <p:graphicFrame xmlns:a="http://schemas.openxmlformats.org/drawingml/2006/main">
-        <p:nvGraphicFramePr>
-          <p:cNvPr id="32" name="Table 31"/>
-          <p:cNvGraphicFramePr>
-            <a:graphicFrameLocks noGrp="1"/>
-          </p:cNvGraphicFramePr>
+      <p:pic xmlns:a="http://schemas.openxmlformats.org/drawingml/2006/main" xmlns:r="http://schemas.openxmlformats.org/officeDocument/2006/relationships">
+        <p:nvPicPr>
+          <p:cNvPr id="32" name="Picture 31" descr="step2_site_grid.png"/>
+          <p:cNvPicPr>
+            <a:picLocks noChangeAspect="1"/>
+          </p:cNvPicPr>
           <p:nvPr/>
-        </p:nvGraphicFramePr>
-        <p:xfrm>
-          <a:off x="4864608" y="3172968"/>
-          <a:ext cx="3776469" cy="1031440"/>
-        </p:xfrm>
-        <a:graphic>
-          <a:graphicData uri="http://schemas.openxmlformats.org/drawingml/2006/table">
-            <a:tbl>
-              <a:tblPr firstRow="1">
-                <a:tableStyleId>{5C22544A-7EE6-4342-B048-85BDC9FD1C3A}</a:tableStyleId>
-              </a:tblPr>
-              <a:tblGrid>
-                <a:gridCol w="1325880"/>
-                <a:gridCol w="816863"/>
-                <a:gridCol w="816863"/>
-                <a:gridCol w="816863"/>
-              </a:tblGrid>
-              <a:tr h="257860">
-                <a:tc>
-                  <a:txBody>
-                    <a:bodyPr/>
-                    <a:lstStyle/>
-                    <a:p>
-                      <a:pPr algn="l"/>
-                      <a:r>
-                        <a:rPr sz="1200" b="1">
-                          <a:solidFill>
-                            <a:srgbClr val="1F2937"/>
-                          </a:solidFill>
-                          <a:latin typeface="Arial"/>
-                        </a:rPr>
-                        <a:t/>
-                      </a:r>
-                    </a:p>
-                  </a:txBody>
-                  <a:tcPr marL="64008" marR="64008" marT="18288" marB="18288">
-                    <a:solidFill>
-                      <a:srgbClr val="EEF2F7"/>
-                    </a:solidFill>
-                  </a:tcPr>
-                </a:tc>
-                <a:tc>
-                  <a:txBody>
-                    <a:bodyPr/>
-                    <a:lstStyle/>
-                    <a:p>
-                      <a:pPr algn="ctr"/>
-                      <a:r>
-                        <a:rPr sz="1200" b="1">
-                          <a:solidFill>
-                            <a:srgbClr val="1F2937"/>
-                          </a:solidFill>
-                          <a:latin typeface="Arial"/>
-                        </a:rPr>
-                        <a:t>free S</a:t>
-                      </a:r>
-                    </a:p>
-                  </a:txBody>
-                  <a:tcPr marL="64008" marR="64008" marT="18288" marB="18288">
-                    <a:solidFill>
-                      <a:srgbClr val="EEF2F7"/>
-                    </a:solidFill>
-                  </a:tcPr>
-                </a:tc>
-                <a:tc>
-                  <a:txBody>
-                    <a:bodyPr/>
-                    <a:lstStyle/>
-                    <a:p>
-                      <a:pPr algn="ctr"/>
-                      <a:r>
-                        <a:rPr sz="1200" b="1">
-                          <a:solidFill>
-                            <a:srgbClr val="1F2937"/>
-                          </a:solidFill>
-                          <a:latin typeface="Arial"/>
-                        </a:rPr>
-                        <a:t>PS₄ corner</a:t>
-                      </a:r>
-                    </a:p>
-                  </a:txBody>
-                  <a:tcPr marL="64008" marR="64008" marT="18288" marB="18288">
-                    <a:solidFill>
-                      <a:srgbClr val="EEF2F7"/>
-                    </a:solidFill>
-                  </a:tcPr>
-                </a:tc>
-                <a:tc>
-                  <a:txBody>
-                    <a:bodyPr/>
-                    <a:lstStyle/>
-                    <a:p>
-                      <a:pPr algn="ctr"/>
-                      <a:r>
-                        <a:rPr sz="1200" b="1">
-                          <a:solidFill>
-                            <a:srgbClr val="1F2937"/>
-                          </a:solidFill>
-                          <a:latin typeface="Arial"/>
-                        </a:rPr>
-                        <a:t>halide</a:t>
-                      </a:r>
-                    </a:p>
-                  </a:txBody>
-                  <a:tcPr marL="64008" marR="64008" marT="18288" marB="18288">
-                    <a:solidFill>
-                      <a:srgbClr val="EEF2F7"/>
-                    </a:solidFill>
-                  </a:tcPr>
-                </a:tc>
-              </a:tr>
-              <a:tr h="257860">
-                <a:tc>
-                  <a:txBody>
-                    <a:bodyPr/>
-                    <a:lstStyle/>
-                    <a:p>
-                      <a:pPr algn="l"/>
-                      <a:r>
-                        <a:rPr sz="1200" b="0">
-                          <a:solidFill>
-                            <a:srgbClr val="374151"/>
-                          </a:solidFill>
-                          <a:latin typeface="Arial"/>
-                        </a:rPr>
-                        <a:t>Li 24g</a:t>
-                      </a:r>
-                    </a:p>
-                  </a:txBody>
-                  <a:tcPr marL="64008" marR="64008" marT="18288" marB="18288">
-                    <a:solidFill>
-                      <a:srgbClr val="FFFFFF"/>
-                    </a:solidFill>
-                  </a:tcPr>
-                </a:tc>
-                <a:tc>
-                  <a:txBody>
-                    <a:bodyPr/>
-                    <a:lstStyle/>
-                    <a:p>
-                      <a:pPr algn="ctr"/>
-                      <a:r>
-                        <a:rPr sz="1200" b="1">
-                          <a:solidFill>
-                            <a:srgbClr val="2563EB"/>
-                          </a:solidFill>
-                          <a:latin typeface="Arial"/>
-                        </a:rPr>
-                        <a:t>1050</a:t>
-                      </a:r>
-                    </a:p>
-                  </a:txBody>
-                  <a:tcPr marL="64008" marR="64008" marT="18288" marB="18288">
-                    <a:solidFill>
-                      <a:srgbClr val="FFFFFF"/>
-                    </a:solidFill>
-                  </a:tcPr>
-                </a:tc>
-                <a:tc>
-                  <a:txBody>
-                    <a:bodyPr/>
-                    <a:lstStyle/>
-                    <a:p>
-                      <a:pPr algn="ctr"/>
-                      <a:r>
-                        <a:rPr sz="1200" b="0">
-                          <a:solidFill>
-                            <a:srgbClr val="374151"/>
-                          </a:solidFill>
-                          <a:latin typeface="Arial"/>
-                        </a:rPr>
-                        <a:t>810</a:t>
-                      </a:r>
-                    </a:p>
-                  </a:txBody>
-                  <a:tcPr marL="64008" marR="64008" marT="18288" marB="18288">
-                    <a:solidFill>
-                      <a:srgbClr val="FFFFFF"/>
-                    </a:solidFill>
-                  </a:tcPr>
-                </a:tc>
-                <a:tc>
-                  <a:txBody>
-                    <a:bodyPr/>
-                    <a:lstStyle/>
-                    <a:p>
-                      <a:pPr algn="ctr"/>
-                      <a:r>
-                        <a:rPr sz="1200" b="0">
-                          <a:solidFill>
-                            <a:srgbClr val="374151"/>
-                          </a:solidFill>
-                          <a:latin typeface="Arial"/>
-                        </a:rPr>
-                        <a:t>600</a:t>
-                      </a:r>
-                    </a:p>
-                  </a:txBody>
-                  <a:tcPr marL="64008" marR="64008" marT="18288" marB="18288">
-                    <a:solidFill>
-                      <a:srgbClr val="FFFFFF"/>
-                    </a:solidFill>
-                  </a:tcPr>
-                </a:tc>
-              </a:tr>
-              <a:tr h="257860">
-                <a:tc>
-                  <a:txBody>
-                    <a:bodyPr/>
-                    <a:lstStyle/>
-                    <a:p>
-                      <a:pPr algn="l"/>
-                      <a:r>
-                        <a:rPr sz="1200" b="0">
-                          <a:solidFill>
-                            <a:srgbClr val="374151"/>
-                          </a:solidFill>
-                          <a:latin typeface="Arial"/>
-                        </a:rPr>
-                        <a:t>P 4b</a:t>
-                      </a:r>
-                    </a:p>
-                  </a:txBody>
-                  <a:tcPr marL="64008" marR="64008" marT="18288" marB="18288">
-                    <a:solidFill>
-                      <a:srgbClr val="FFFFFF"/>
-                    </a:solidFill>
-                  </a:tcPr>
-                </a:tc>
-                <a:tc>
-                  <a:txBody>
-                    <a:bodyPr/>
-                    <a:lstStyle/>
-                    <a:p>
-                      <a:pPr algn="ctr"/>
-                      <a:r>
-                        <a:rPr sz="1200" b="0">
-                          <a:solidFill>
-                            <a:srgbClr val="374151"/>
-                          </a:solidFill>
-                          <a:latin typeface="Arial"/>
-                        </a:rPr>
-                        <a:t>375</a:t>
-                      </a:r>
-                    </a:p>
-                  </a:txBody>
-                  <a:tcPr marL="64008" marR="64008" marT="18288" marB="18288">
-                    <a:solidFill>
-                      <a:srgbClr val="FFFFFF"/>
-                    </a:solidFill>
-                  </a:tcPr>
-                </a:tc>
-                <a:tc>
-                  <a:txBody>
-                    <a:bodyPr/>
-                    <a:lstStyle/>
-                    <a:p>
-                      <a:pPr algn="ctr"/>
-                      <a:r>
-                        <a:rPr sz="1200" b="0">
-                          <a:solidFill>
-                            <a:srgbClr val="374151"/>
-                          </a:solidFill>
-                          <a:latin typeface="Arial"/>
-                        </a:rPr>
-                        <a:t>270</a:t>
-                      </a:r>
-                    </a:p>
-                  </a:txBody>
-                  <a:tcPr marL="64008" marR="64008" marT="18288" marB="18288">
-                    <a:solidFill>
-                      <a:srgbClr val="FFFFFF"/>
-                    </a:solidFill>
-                  </a:tcPr>
-                </a:tc>
-                <a:tc>
-                  <a:txBody>
-                    <a:bodyPr/>
-                    <a:lstStyle/>
-                    <a:p>
-                      <a:pPr algn="ctr"/>
-                      <a:r>
-                        <a:rPr sz="1200" b="0">
-                          <a:solidFill>
-                            <a:srgbClr val="374151"/>
-                          </a:solidFill>
-                          <a:latin typeface="Arial"/>
-                        </a:rPr>
-                        <a:t>180</a:t>
-                      </a:r>
-                    </a:p>
-                  </a:txBody>
-                  <a:tcPr marL="64008" marR="64008" marT="18288" marB="18288">
-                    <a:solidFill>
-                      <a:srgbClr val="FFFFFF"/>
-                    </a:solidFill>
-                  </a:tcPr>
-                </a:tc>
-              </a:tr>
-              <a:tr h="257860">
-                <a:tc>
-                  <a:txBody>
-                    <a:bodyPr/>
-                    <a:lstStyle/>
-                    <a:p>
-                      <a:pPr algn="l"/>
-                      <a:r>
-                        <a:rPr sz="1200" b="0">
-                          <a:solidFill>
-                            <a:srgbClr val="374151"/>
-                          </a:solidFill>
-                          <a:latin typeface="Arial"/>
-                        </a:rPr>
-                        <a:t>Li 48h</a:t>
-                      </a:r>
-                    </a:p>
-                  </a:txBody>
-                  <a:tcPr marL="64008" marR="64008" marT="18288" marB="18288">
-                    <a:solidFill>
-                      <a:srgbClr val="FFFFFF"/>
-                    </a:solidFill>
-                  </a:tcPr>
-                </a:tc>
-                <a:tc>
-                  <a:txBody>
-                    <a:bodyPr/>
-                    <a:lstStyle/>
-                    <a:p>
-                      <a:pPr algn="ctr"/>
-                      <a:r>
-                        <a:rPr sz="1200" b="0">
-                          <a:solidFill>
-                            <a:srgbClr val="374151"/>
-                          </a:solidFill>
-                          <a:latin typeface="Arial"/>
-                        </a:rPr>
-                        <a:t>120</a:t>
-                      </a:r>
-                    </a:p>
-                  </a:txBody>
-                  <a:tcPr marL="64008" marR="64008" marT="18288" marB="18288">
-                    <a:solidFill>
-                      <a:srgbClr val="FFFFFF"/>
-                    </a:solidFill>
-                  </a:tcPr>
-                </a:tc>
-                <a:tc>
-                  <a:txBody>
-                    <a:bodyPr/>
-                    <a:lstStyle/>
-                    <a:p>
-                      <a:pPr algn="ctr"/>
-                      <a:r>
-                        <a:rPr sz="1200" b="0">
-                          <a:solidFill>
-                            <a:srgbClr val="374151"/>
-                          </a:solidFill>
-                          <a:latin typeface="Arial"/>
-                        </a:rPr>
-                        <a:t>105</a:t>
-                      </a:r>
-                    </a:p>
-                  </a:txBody>
-                  <a:tcPr marL="64008" marR="64008" marT="18288" marB="18288">
-                    <a:solidFill>
-                      <a:srgbClr val="FFFFFF"/>
-                    </a:solidFill>
-                  </a:tcPr>
-                </a:tc>
-                <a:tc>
-                  <a:txBody>
-                    <a:bodyPr/>
-                    <a:lstStyle/>
-                    <a:p>
-                      <a:pPr algn="ctr"/>
-                      <a:r>
-                        <a:rPr sz="1200" b="0">
-                          <a:solidFill>
-                            <a:srgbClr val="374151"/>
-                          </a:solidFill>
-                          <a:latin typeface="Arial"/>
-                        </a:rPr>
-                        <a:t>105</a:t>
-                      </a:r>
-                    </a:p>
-                  </a:txBody>
-                  <a:tcPr marL="64008" marR="64008" marT="18288" marB="18288">
-                    <a:solidFill>
-                      <a:srgbClr val="FFFFFF"/>
-                    </a:solidFill>
-                  </a:tcPr>
-                </a:tc>
-              </a:tr>
-            </a:tbl>
-          </a:graphicData>
-        </a:graphic>
-      </p:graphicFrame>
+        </p:nvPicPr>
+        <p:blipFill>
+          <a:blip r:embed="rId5"/>
+          <a:stretch>
+            <a:fillRect/>
+          </a:stretch>
+        </p:blipFill>
+        <p:spPr>
+          <a:xfrm>
+            <a:off x="4672583" y="2773923"/>
+            <a:ext cx="3968496" cy="1913656"/>
+          </a:xfrm>
+          <a:prstGeom prst="rect">
+            <a:avLst/>
+          </a:prstGeom>
+        </p:spPr>
+      </p:pic>
       <p:sp xmlns:a="http://schemas.openxmlformats.org/drawingml/2006/main">
         <p:nvSpPr>
           <p:cNvPr id="33" name="TextBox 32"/>
@@ -2343,7 +1963,7 @@
                 </a:solidFill>
                 <a:latin typeface="Arial"/>
               </a:rPr>
-              <a:t>&lt; where the anion landed  ·  structures per site pair (cation ↓ / anion →) &gt;</a:t>
+              <a:t>&lt; where the anion landed  ·  structures per site pair &gt;</a:t>
             </a:r>
           </a:p>
         </p:txBody>

</xml_diff>